<commit_message>
Update PowerPoint presentation with card-based designs and embedded custom PNG illustrations
</commit_message>
<xml_diff>
--- a/Talkies_Project_Presentation.pptx
+++ b/Talkies_Project_Presentation.pptx
@@ -3107,14 +3107,57 @@
       <p:grpSpPr/>
       <p:sp>
         <p:nvSpPr>
-          <p:cNvPr id="2" name="TextBox 1"/>
+          <p:cNvPr id="2" name="Rectangle 1"/>
+          <p:cNvSpPr/>
+          <p:nvPr/>
+        </p:nvSpPr>
+        <p:spPr>
+          <a:xfrm>
+            <a:off x="914400" y="1371600"/>
+            <a:ext cx="10360152" cy="4114800"/>
+          </a:xfrm>
+          <a:prstGeom prst="rect">
+            <a:avLst/>
+          </a:prstGeom>
+          <a:solidFill>
+            <a:srgbClr val="075E54"/>
+          </a:solidFill>
+          <a:ln>
+            <a:noFill/>
+          </a:ln>
+        </p:spPr>
+        <p:style>
+          <a:lnRef idx="1">
+            <a:schemeClr val="accent1"/>
+          </a:lnRef>
+          <a:fillRef idx="3">
+            <a:schemeClr val="accent1"/>
+          </a:fillRef>
+          <a:effectRef idx="2">
+            <a:schemeClr val="accent1"/>
+          </a:effectRef>
+          <a:fontRef idx="minor">
+            <a:schemeClr val="lt1"/>
+          </a:fontRef>
+        </p:style>
+        <p:txBody>
+          <a:bodyPr rtlCol="0" anchor="ctr"/>
+          <a:lstStyle/>
+          <a:p>
+            <a:pPr algn="ctr"/>
+          </a:p>
+        </p:txBody>
+      </p:sp>
+      <p:sp>
+        <p:nvSpPr>
+          <p:cNvPr id="3" name="TextBox 2"/>
           <p:cNvSpPr txBox="1"/>
           <p:nvPr/>
         </p:nvSpPr>
         <p:spPr>
           <a:xfrm>
-            <a:off x="914400" y="1828800"/>
-            <a:ext cx="10360152" cy="3657600"/>
+            <a:off x="1371600" y="1828800"/>
+            <a:ext cx="9445752" cy="3200400"/>
           </a:xfrm>
           <a:prstGeom prst="rect">
             <a:avLst/>
@@ -3122,7 +3165,7 @@
           <a:noFill/>
         </p:spPr>
         <p:txBody>
-          <a:bodyPr wrap="none">
+          <a:bodyPr wrap="square">
             <a:spAutoFit/>
           </a:bodyPr>
           <a:lstStyle/>
@@ -3132,7 +3175,7 @@
                 <a:solidFill>
                   <a:srgbClr val="FFFFFF"/>
                 </a:solidFill>
-                <a:latin typeface="Arial"/>
+                <a:latin typeface="Segoe UI"/>
               </a:defRPr>
             </a:pPr>
             <a:r>
@@ -3146,9 +3189,9 @@
               </a:spcBef>
               <a:defRPr sz="2400">
                 <a:solidFill>
-                  <a:srgbClr val="F0F2F5"/>
-                </a:solidFill>
-                <a:latin typeface="Arial"/>
+                  <a:srgbClr val="F5F6F8"/>
+                </a:solidFill>
+                <a:latin typeface="Segoe UI"/>
               </a:defRPr>
             </a:pPr>
             <a:r>
@@ -3164,7 +3207,7 @@
                 <a:solidFill>
                   <a:srgbClr val="FFFFFF"/>
                 </a:solidFill>
-                <a:latin typeface="Arial"/>
+                <a:latin typeface="Segoe UI"/>
               </a:defRPr>
             </a:pPr>
             <a:r>
@@ -3187,7 +3230,7 @@
     <p:bg>
       <p:bgPr>
         <a:solidFill>
-          <a:srgbClr val="F0F2F5"/>
+          <a:srgbClr val="F5F6F8"/>
         </a:solidFill>
         <a:effectLst/>
       </p:bgPr>
@@ -3237,7 +3280,7 @@
           </a:fontRef>
         </p:style>
         <p:txBody>
-          <a:bodyPr rtlCol="0" anchor="ctr" wrap="square" lIns="457200" tIns="274320"/>
+          <a:bodyPr rtlCol="0" anchor="ctr" wrap="square" lIns="548640" tIns="320040"/>
           <a:lstStyle/>
           <a:p>
             <a:pPr algn="l">
@@ -3245,7 +3288,7 @@
                 <a:solidFill>
                   <a:srgbClr val="FFFFFF"/>
                 </a:solidFill>
-                <a:latin typeface="Arial"/>
+                <a:latin typeface="Segoe UI"/>
               </a:defRPr>
             </a:pPr>
             <a:r>
@@ -3256,14 +3299,59 @@
       </p:sp>
       <p:sp>
         <p:nvSpPr>
-          <p:cNvPr id="3" name="TextBox 2"/>
+          <p:cNvPr id="3" name="Rectangle 2"/>
+          <p:cNvSpPr/>
+          <p:nvPr/>
+        </p:nvSpPr>
+        <p:spPr>
+          <a:xfrm>
+            <a:off x="457200" y="1371600"/>
+            <a:ext cx="11274552" cy="5029200"/>
+          </a:xfrm>
+          <a:prstGeom prst="rect">
+            <a:avLst/>
+          </a:prstGeom>
+          <a:solidFill>
+            <a:srgbClr val="FFFFFF"/>
+          </a:solidFill>
+          <a:ln w="12700">
+            <a:solidFill>
+              <a:srgbClr val="E1E4E8"/>
+            </a:solidFill>
+          </a:ln>
+        </p:spPr>
+        <p:style>
+          <a:lnRef idx="1">
+            <a:schemeClr val="accent1"/>
+          </a:lnRef>
+          <a:fillRef idx="3">
+            <a:schemeClr val="accent1"/>
+          </a:fillRef>
+          <a:effectRef idx="2">
+            <a:schemeClr val="accent1"/>
+          </a:effectRef>
+          <a:fontRef idx="minor">
+            <a:schemeClr val="lt1"/>
+          </a:fontRef>
+        </p:style>
+        <p:txBody>
+          <a:bodyPr rtlCol="0" anchor="ctr"/>
+          <a:lstStyle/>
+          <a:p>
+            <a:pPr algn="ctr"/>
+          </a:p>
+        </p:txBody>
+      </p:sp>
+      <p:sp>
+        <p:nvSpPr>
+          <p:cNvPr id="4" name="TextBox 3"/>
           <p:cNvSpPr txBox="1"/>
           <p:nvPr/>
         </p:nvSpPr>
         <p:spPr>
           <a:xfrm>
-            <a:off x="457200" y="1463040"/>
-            <a:ext cx="11274552" cy="4937760"/>
+            <a:off x="731520" y="1554480"/>
+            <a:ext cx="10725912" cy="4663440"/>
           </a:xfrm>
           <a:prstGeom prst="rect">
             <a:avLst/>
@@ -3282,9 +3370,9 @@
               </a:spcAft>
               <a:defRPr sz="1800">
                 <a:solidFill>
-                  <a:srgbClr val="282828"/>
-                </a:solidFill>
-                <a:latin typeface="Arial"/>
+                  <a:srgbClr val="2C3E50"/>
+                </a:solidFill>
+                <a:latin typeface="Segoe UI"/>
               </a:defRPr>
             </a:pPr>
             <a:r>
@@ -3298,9 +3386,9 @@
               </a:spcAft>
               <a:defRPr sz="1600">
                 <a:solidFill>
-                  <a:srgbClr val="282828"/>
-                </a:solidFill>
-                <a:latin typeface="Arial"/>
+                  <a:srgbClr val="2C3E50"/>
+                </a:solidFill>
+                <a:latin typeface="Segoe UI"/>
               </a:defRPr>
             </a:pPr>
             <a:r>
@@ -3314,9 +3402,9 @@
               </a:spcAft>
               <a:defRPr sz="1600">
                 <a:solidFill>
-                  <a:srgbClr val="282828"/>
-                </a:solidFill>
-                <a:latin typeface="Arial"/>
+                  <a:srgbClr val="2C3E50"/>
+                </a:solidFill>
+                <a:latin typeface="Segoe UI"/>
               </a:defRPr>
             </a:pPr>
             <a:r>
@@ -3330,9 +3418,9 @@
               </a:spcAft>
               <a:defRPr sz="1800">
                 <a:solidFill>
-                  <a:srgbClr val="282828"/>
-                </a:solidFill>
-                <a:latin typeface="Arial"/>
+                  <a:srgbClr val="2C3E50"/>
+                </a:solidFill>
+                <a:latin typeface="Segoe UI"/>
               </a:defRPr>
             </a:pPr>
             <a:r>
@@ -3346,9 +3434,9 @@
               </a:spcAft>
               <a:defRPr sz="1600">
                 <a:solidFill>
-                  <a:srgbClr val="282828"/>
-                </a:solidFill>
-                <a:latin typeface="Arial"/>
+                  <a:srgbClr val="2C3E50"/>
+                </a:solidFill>
+                <a:latin typeface="Segoe UI"/>
               </a:defRPr>
             </a:pPr>
             <a:r>
@@ -3362,9 +3450,9 @@
               </a:spcAft>
               <a:defRPr sz="1600">
                 <a:solidFill>
-                  <a:srgbClr val="282828"/>
-                </a:solidFill>
-                <a:latin typeface="Arial"/>
+                  <a:srgbClr val="2C3E50"/>
+                </a:solidFill>
+                <a:latin typeface="Segoe UI"/>
               </a:defRPr>
             </a:pPr>
             <a:r>
@@ -3378,9 +3466,9 @@
               </a:spcAft>
               <a:defRPr sz="1800">
                 <a:solidFill>
-                  <a:srgbClr val="282828"/>
-                </a:solidFill>
-                <a:latin typeface="Arial"/>
+                  <a:srgbClr val="2C3E50"/>
+                </a:solidFill>
+                <a:latin typeface="Segoe UI"/>
               </a:defRPr>
             </a:pPr>
             <a:r>
@@ -3394,9 +3482,9 @@
               </a:spcAft>
               <a:defRPr sz="1600">
                 <a:solidFill>
-                  <a:srgbClr val="282828"/>
-                </a:solidFill>
-                <a:latin typeface="Arial"/>
+                  <a:srgbClr val="2C3E50"/>
+                </a:solidFill>
+                <a:latin typeface="Segoe UI"/>
               </a:defRPr>
             </a:pPr>
             <a:r>
@@ -3410,9 +3498,9 @@
               </a:spcAft>
               <a:defRPr sz="1600">
                 <a:solidFill>
-                  <a:srgbClr val="282828"/>
-                </a:solidFill>
-                <a:latin typeface="Arial"/>
+                  <a:srgbClr val="2C3E50"/>
+                </a:solidFill>
+                <a:latin typeface="Segoe UI"/>
               </a:defRPr>
             </a:pPr>
             <a:r>
@@ -3435,7 +3523,7 @@
     <p:bg>
       <p:bgPr>
         <a:solidFill>
-          <a:srgbClr val="F0F2F5"/>
+          <a:srgbClr val="F5F6F8"/>
         </a:solidFill>
         <a:effectLst/>
       </p:bgPr>
@@ -3485,7 +3573,7 @@
           </a:fontRef>
         </p:style>
         <p:txBody>
-          <a:bodyPr rtlCol="0" anchor="ctr" wrap="square" lIns="457200" tIns="274320"/>
+          <a:bodyPr rtlCol="0" anchor="ctr" wrap="square" lIns="548640" tIns="320040"/>
           <a:lstStyle/>
           <a:p>
             <a:pPr algn="l">
@@ -3493,7 +3581,7 @@
                 <a:solidFill>
                   <a:srgbClr val="FFFFFF"/>
                 </a:solidFill>
-                <a:latin typeface="Arial"/>
+                <a:latin typeface="Segoe UI"/>
               </a:defRPr>
             </a:pPr>
             <a:r>
@@ -3504,14 +3592,59 @@
       </p:sp>
       <p:sp>
         <p:nvSpPr>
-          <p:cNvPr id="3" name="TextBox 2"/>
+          <p:cNvPr id="3" name="Rectangle 2"/>
+          <p:cNvSpPr/>
+          <p:nvPr/>
+        </p:nvSpPr>
+        <p:spPr>
+          <a:xfrm>
+            <a:off x="457200" y="1371600"/>
+            <a:ext cx="11274552" cy="5029200"/>
+          </a:xfrm>
+          <a:prstGeom prst="rect">
+            <a:avLst/>
+          </a:prstGeom>
+          <a:solidFill>
+            <a:srgbClr val="FFFFFF"/>
+          </a:solidFill>
+          <a:ln w="12700">
+            <a:solidFill>
+              <a:srgbClr val="E1E4E8"/>
+            </a:solidFill>
+          </a:ln>
+        </p:spPr>
+        <p:style>
+          <a:lnRef idx="1">
+            <a:schemeClr val="accent1"/>
+          </a:lnRef>
+          <a:fillRef idx="3">
+            <a:schemeClr val="accent1"/>
+          </a:fillRef>
+          <a:effectRef idx="2">
+            <a:schemeClr val="accent1"/>
+          </a:effectRef>
+          <a:fontRef idx="minor">
+            <a:schemeClr val="lt1"/>
+          </a:fontRef>
+        </p:style>
+        <p:txBody>
+          <a:bodyPr rtlCol="0" anchor="ctr"/>
+          <a:lstStyle/>
+          <a:p>
+            <a:pPr algn="ctr"/>
+          </a:p>
+        </p:txBody>
+      </p:sp>
+      <p:sp>
+        <p:nvSpPr>
+          <p:cNvPr id="4" name="TextBox 3"/>
           <p:cNvSpPr txBox="1"/>
           <p:nvPr/>
         </p:nvSpPr>
         <p:spPr>
           <a:xfrm>
-            <a:off x="457200" y="1463040"/>
-            <a:ext cx="11274552" cy="4937760"/>
+            <a:off x="731520" y="1554480"/>
+            <a:ext cx="10725912" cy="4663440"/>
           </a:xfrm>
           <a:prstGeom prst="rect">
             <a:avLst/>
@@ -3530,9 +3663,9 @@
               </a:spcAft>
               <a:defRPr sz="1800">
                 <a:solidFill>
-                  <a:srgbClr val="282828"/>
-                </a:solidFill>
-                <a:latin typeface="Arial"/>
+                  <a:srgbClr val="2C3E50"/>
+                </a:solidFill>
+                <a:latin typeface="Segoe UI"/>
               </a:defRPr>
             </a:pPr>
             <a:r>
@@ -3546,9 +3679,9 @@
               </a:spcAft>
               <a:defRPr sz="1600">
                 <a:solidFill>
-                  <a:srgbClr val="282828"/>
-                </a:solidFill>
-                <a:latin typeface="Arial"/>
+                  <a:srgbClr val="2C3E50"/>
+                </a:solidFill>
+                <a:latin typeface="Segoe UI"/>
               </a:defRPr>
             </a:pPr>
             <a:r>
@@ -3562,9 +3695,9 @@
               </a:spcAft>
               <a:defRPr sz="1600">
                 <a:solidFill>
-                  <a:srgbClr val="282828"/>
-                </a:solidFill>
-                <a:latin typeface="Arial"/>
+                  <a:srgbClr val="2C3E50"/>
+                </a:solidFill>
+                <a:latin typeface="Segoe UI"/>
               </a:defRPr>
             </a:pPr>
             <a:r>
@@ -3578,9 +3711,9 @@
               </a:spcAft>
               <a:defRPr sz="1600">
                 <a:solidFill>
-                  <a:srgbClr val="282828"/>
-                </a:solidFill>
-                <a:latin typeface="Arial"/>
+                  <a:srgbClr val="2C3E50"/>
+                </a:solidFill>
+                <a:latin typeface="Segoe UI"/>
               </a:defRPr>
             </a:pPr>
             <a:r>
@@ -3594,9 +3727,9 @@
               </a:spcAft>
               <a:defRPr sz="1800">
                 <a:solidFill>
-                  <a:srgbClr val="282828"/>
-                </a:solidFill>
-                <a:latin typeface="Arial"/>
+                  <a:srgbClr val="2C3E50"/>
+                </a:solidFill>
+                <a:latin typeface="Segoe UI"/>
               </a:defRPr>
             </a:pPr>
             <a:r>
@@ -3610,9 +3743,9 @@
               </a:spcAft>
               <a:defRPr sz="1600">
                 <a:solidFill>
-                  <a:srgbClr val="282828"/>
-                </a:solidFill>
-                <a:latin typeface="Arial"/>
+                  <a:srgbClr val="2C3E50"/>
+                </a:solidFill>
+                <a:latin typeface="Segoe UI"/>
               </a:defRPr>
             </a:pPr>
             <a:r>
@@ -3626,9 +3759,9 @@
               </a:spcAft>
               <a:defRPr sz="1600">
                 <a:solidFill>
-                  <a:srgbClr val="282828"/>
-                </a:solidFill>
-                <a:latin typeface="Arial"/>
+                  <a:srgbClr val="2C3E50"/>
+                </a:solidFill>
+                <a:latin typeface="Segoe UI"/>
               </a:defRPr>
             </a:pPr>
             <a:r>
@@ -3642,9 +3775,9 @@
               </a:spcAft>
               <a:defRPr sz="1600">
                 <a:solidFill>
-                  <a:srgbClr val="282828"/>
-                </a:solidFill>
-                <a:latin typeface="Arial"/>
+                  <a:srgbClr val="2C3E50"/>
+                </a:solidFill>
+                <a:latin typeface="Segoe UI"/>
               </a:defRPr>
             </a:pPr>
             <a:r>
@@ -3667,7 +3800,7 @@
     <p:bg>
       <p:bgPr>
         <a:solidFill>
-          <a:srgbClr val="F0F2F5"/>
+          <a:srgbClr val="F5F6F8"/>
         </a:solidFill>
         <a:effectLst/>
       </p:bgPr>
@@ -3717,7 +3850,7 @@
           </a:fontRef>
         </p:style>
         <p:txBody>
-          <a:bodyPr rtlCol="0" anchor="ctr" wrap="square" lIns="457200" tIns="274320"/>
+          <a:bodyPr rtlCol="0" anchor="ctr" wrap="square" lIns="548640" tIns="320040"/>
           <a:lstStyle/>
           <a:p>
             <a:pPr algn="l">
@@ -3725,7 +3858,7 @@
                 <a:solidFill>
                   <a:srgbClr val="FFFFFF"/>
                 </a:solidFill>
-                <a:latin typeface="Arial"/>
+                <a:latin typeface="Segoe UI"/>
               </a:defRPr>
             </a:pPr>
             <a:r>
@@ -3736,14 +3869,59 @@
       </p:sp>
       <p:sp>
         <p:nvSpPr>
-          <p:cNvPr id="3" name="TextBox 2"/>
+          <p:cNvPr id="3" name="Rectangle 2"/>
+          <p:cNvSpPr/>
+          <p:nvPr/>
+        </p:nvSpPr>
+        <p:spPr>
+          <a:xfrm>
+            <a:off x="457200" y="1371600"/>
+            <a:ext cx="6583680" cy="5029200"/>
+          </a:xfrm>
+          <a:prstGeom prst="rect">
+            <a:avLst/>
+          </a:prstGeom>
+          <a:solidFill>
+            <a:srgbClr val="FFFFFF"/>
+          </a:solidFill>
+          <a:ln w="12700">
+            <a:solidFill>
+              <a:srgbClr val="E1E4E8"/>
+            </a:solidFill>
+          </a:ln>
+        </p:spPr>
+        <p:style>
+          <a:lnRef idx="1">
+            <a:schemeClr val="accent1"/>
+          </a:lnRef>
+          <a:fillRef idx="3">
+            <a:schemeClr val="accent1"/>
+          </a:fillRef>
+          <a:effectRef idx="2">
+            <a:schemeClr val="accent1"/>
+          </a:effectRef>
+          <a:fontRef idx="minor">
+            <a:schemeClr val="lt1"/>
+          </a:fontRef>
+        </p:style>
+        <p:txBody>
+          <a:bodyPr rtlCol="0" anchor="ctr"/>
+          <a:lstStyle/>
+          <a:p>
+            <a:pPr algn="ctr"/>
+          </a:p>
+        </p:txBody>
+      </p:sp>
+      <p:sp>
+        <p:nvSpPr>
+          <p:cNvPr id="4" name="TextBox 3"/>
           <p:cNvSpPr txBox="1"/>
           <p:nvPr/>
         </p:nvSpPr>
         <p:spPr>
           <a:xfrm>
-            <a:off x="457200" y="1463040"/>
-            <a:ext cx="11274552" cy="4937760"/>
+            <a:off x="640080" y="1554480"/>
+            <a:ext cx="6217920" cy="4663440"/>
           </a:xfrm>
           <a:prstGeom prst="rect">
             <a:avLst/>
@@ -3762,9 +3940,9 @@
               </a:spcAft>
               <a:defRPr sz="1800">
                 <a:solidFill>
-                  <a:srgbClr val="282828"/>
-                </a:solidFill>
-                <a:latin typeface="Arial"/>
+                  <a:srgbClr val="2C3E50"/>
+                </a:solidFill>
+                <a:latin typeface="Segoe UI"/>
               </a:defRPr>
             </a:pPr>
             <a:r>
@@ -3778,13 +3956,13 @@
               </a:spcAft>
               <a:defRPr sz="1600">
                 <a:solidFill>
-                  <a:srgbClr val="282828"/>
-                </a:solidFill>
-                <a:latin typeface="Arial"/>
-              </a:defRPr>
-            </a:pPr>
-            <a:r>
-              <a:t>React.js &amp; TailwindCSS for responsive, modern layout design.</a:t>
+                  <a:srgbClr val="2C3E50"/>
+                </a:solidFill>
+                <a:latin typeface="Segoe UI"/>
+              </a:defRPr>
+            </a:pPr>
+            <a:r>
+              <a:t>React.js &amp; TailwindCSS for responsive layouts.</a:t>
             </a:r>
           </a:p>
           <a:p>
@@ -3794,13 +3972,13 @@
               </a:spcAft>
               <a:defRPr sz="1600">
                 <a:solidFill>
-                  <a:srgbClr val="282828"/>
-                </a:solidFill>
-                <a:latin typeface="Arial"/>
-              </a:defRPr>
-            </a:pPr>
-            <a:r>
-              <a:t>Zustand for lightweight, decoupled client-side state management.</a:t>
+                  <a:srgbClr val="2C3E50"/>
+                </a:solidFill>
+                <a:latin typeface="Segoe UI"/>
+              </a:defRPr>
+            </a:pPr>
+            <a:r>
+              <a:t>Zustand for lightweight client state management.</a:t>
             </a:r>
           </a:p>
           <a:p>
@@ -3810,13 +3988,13 @@
               </a:spcAft>
               <a:defRPr sz="1600">
                 <a:solidFill>
-                  <a:srgbClr val="282828"/>
-                </a:solidFill>
-                <a:latin typeface="Arial"/>
-              </a:defRPr>
-            </a:pPr>
-            <a:r>
-              <a:t>Framer Motion for premium user interface transitions.</a:t>
+                  <a:srgbClr val="2C3E50"/>
+                </a:solidFill>
+                <a:latin typeface="Segoe UI"/>
+              </a:defRPr>
+            </a:pPr>
+            <a:r>
+              <a:t>Framer Motion for premium UI transitions.</a:t>
             </a:r>
           </a:p>
           <a:p>
@@ -3826,9 +4004,9 @@
               </a:spcAft>
               <a:defRPr sz="1800">
                 <a:solidFill>
-                  <a:srgbClr val="282828"/>
-                </a:solidFill>
-                <a:latin typeface="Arial"/>
+                  <a:srgbClr val="2C3E50"/>
+                </a:solidFill>
+                <a:latin typeface="Segoe UI"/>
               </a:defRPr>
             </a:pPr>
             <a:r>
@@ -3842,13 +4020,13 @@
               </a:spcAft>
               <a:defRPr sz="1600">
                 <a:solidFill>
-                  <a:srgbClr val="282828"/>
-                </a:solidFill>
-                <a:latin typeface="Arial"/>
-              </a:defRPr>
-            </a:pPr>
-            <a:r>
-              <a:t>Node.js &amp; Express.js for REST API routes and business logic.</a:t>
+                  <a:srgbClr val="2C3E50"/>
+                </a:solidFill>
+                <a:latin typeface="Segoe UI"/>
+              </a:defRPr>
+            </a:pPr>
+            <a:r>
+              <a:t>Node.js &amp; Express.js for REST API routes.</a:t>
             </a:r>
           </a:p>
           <a:p>
@@ -3858,13 +4036,13 @@
               </a:spcAft>
               <a:defRPr sz="1600">
                 <a:solidFill>
-                  <a:srgbClr val="282828"/>
-                </a:solidFill>
-                <a:latin typeface="Arial"/>
-              </a:defRPr>
-            </a:pPr>
-            <a:r>
-              <a:t>Socket.io for WebSocket bidirectional messaging and state signals.</a:t>
+                  <a:srgbClr val="2C3E50"/>
+                </a:solidFill>
+                <a:latin typeface="Segoe UI"/>
+              </a:defRPr>
+            </a:pPr>
+            <a:r>
+              <a:t>Socket.io for WebSocket bidirectional messaging.</a:t>
             </a:r>
           </a:p>
           <a:p>
@@ -3874,13 +4052,13 @@
               </a:spcAft>
               <a:defRPr sz="1600">
                 <a:solidFill>
-                  <a:srgbClr val="282828"/>
-                </a:solidFill>
-                <a:latin typeface="Arial"/>
-              </a:defRPr>
-            </a:pPr>
-            <a:r>
-              <a:t>WebRTC for browser-to-browser direct media streaming.</a:t>
+                  <a:srgbClr val="2C3E50"/>
+                </a:solidFill>
+                <a:latin typeface="Segoe UI"/>
+              </a:defRPr>
+            </a:pPr>
+            <a:r>
+              <a:t>WebRTC for browser-to-browser media streaming.</a:t>
             </a:r>
           </a:p>
           <a:p>
@@ -3890,9 +4068,9 @@
               </a:spcAft>
               <a:defRPr sz="1800">
                 <a:solidFill>
-                  <a:srgbClr val="282828"/>
-                </a:solidFill>
-                <a:latin typeface="Arial"/>
+                  <a:srgbClr val="2C3E50"/>
+                </a:solidFill>
+                <a:latin typeface="Segoe UI"/>
               </a:defRPr>
             </a:pPr>
             <a:r>
@@ -3906,13 +4084,13 @@
               </a:spcAft>
               <a:defRPr sz="1600">
                 <a:solidFill>
-                  <a:srgbClr val="282828"/>
-                </a:solidFill>
-                <a:latin typeface="Arial"/>
-              </a:defRPr>
-            </a:pPr>
-            <a:r>
-              <a:t>MongoDB for structured collections (Users, Messages, Conversations, Requests).</a:t>
+                  <a:srgbClr val="2C3E50"/>
+                </a:solidFill>
+                <a:latin typeface="Segoe UI"/>
+              </a:defRPr>
+            </a:pPr>
+            <a:r>
+              <a:t>MongoDB for structured collections.</a:t>
             </a:r>
           </a:p>
           <a:p>
@@ -3922,17 +4100,86 @@
               </a:spcAft>
               <a:defRPr sz="1600">
                 <a:solidFill>
-                  <a:srgbClr val="282828"/>
-                </a:solidFill>
-                <a:latin typeface="Arial"/>
-              </a:defRPr>
-            </a:pPr>
-            <a:r>
-              <a:t>Cloudinary for scalable cloud-based media assets hosting.</a:t>
-            </a:r>
-          </a:p>
-        </p:txBody>
-      </p:sp>
+                  <a:srgbClr val="2C3E50"/>
+                </a:solidFill>
+                <a:latin typeface="Segoe UI"/>
+              </a:defRPr>
+            </a:pPr>
+            <a:r>
+              <a:t>Cloudinary for scalable cloud media hosting.</a:t>
+            </a:r>
+          </a:p>
+        </p:txBody>
+      </p:sp>
+      <p:sp>
+        <p:nvSpPr>
+          <p:cNvPr id="5" name="Rectangle 4"/>
+          <p:cNvSpPr/>
+          <p:nvPr/>
+        </p:nvSpPr>
+        <p:spPr>
+          <a:xfrm>
+            <a:off x="7315200" y="1371600"/>
+            <a:ext cx="4416552" cy="5029200"/>
+          </a:xfrm>
+          <a:prstGeom prst="rect">
+            <a:avLst/>
+          </a:prstGeom>
+          <a:solidFill>
+            <a:srgbClr val="FFFFFF"/>
+          </a:solidFill>
+          <a:ln w="12700">
+            <a:solidFill>
+              <a:srgbClr val="E1E4E8"/>
+            </a:solidFill>
+          </a:ln>
+        </p:spPr>
+        <p:style>
+          <a:lnRef idx="1">
+            <a:schemeClr val="accent1"/>
+          </a:lnRef>
+          <a:fillRef idx="3">
+            <a:schemeClr val="accent1"/>
+          </a:fillRef>
+          <a:effectRef idx="2">
+            <a:schemeClr val="accent1"/>
+          </a:effectRef>
+          <a:fontRef idx="minor">
+            <a:schemeClr val="lt1"/>
+          </a:fontRef>
+        </p:style>
+        <p:txBody>
+          <a:bodyPr rtlCol="0" anchor="ctr"/>
+          <a:lstStyle/>
+          <a:p>
+            <a:pPr algn="ctr"/>
+          </a:p>
+        </p:txBody>
+      </p:sp>
+      <p:pic>
+        <p:nvPicPr>
+          <p:cNvPr id="6" name="Picture 5" descr="architecture.png"/>
+          <p:cNvPicPr>
+            <a:picLocks noChangeAspect="1"/>
+          </p:cNvPicPr>
+          <p:nvPr/>
+        </p:nvPicPr>
+        <p:blipFill>
+          <a:blip r:embed="rId2"/>
+          <a:stretch>
+            <a:fillRect/>
+          </a:stretch>
+        </p:blipFill>
+        <p:spPr>
+          <a:xfrm>
+            <a:off x="7498079" y="1554480"/>
+            <a:ext cx="4050791" cy="4663440"/>
+          </a:xfrm>
+          <a:prstGeom prst="rect">
+            <a:avLst/>
+          </a:prstGeom>
+        </p:spPr>
+      </p:pic>
     </p:spTree>
   </p:cSld>
   <p:clrMapOvr>
@@ -3947,7 +4194,7 @@
     <p:bg>
       <p:bgPr>
         <a:solidFill>
-          <a:srgbClr val="F0F2F5"/>
+          <a:srgbClr val="F5F6F8"/>
         </a:solidFill>
         <a:effectLst/>
       </p:bgPr>
@@ -3997,7 +4244,7 @@
           </a:fontRef>
         </p:style>
         <p:txBody>
-          <a:bodyPr rtlCol="0" anchor="ctr" wrap="square" lIns="457200" tIns="274320"/>
+          <a:bodyPr rtlCol="0" anchor="ctr" wrap="square" lIns="548640" tIns="320040"/>
           <a:lstStyle/>
           <a:p>
             <a:pPr algn="l">
@@ -4005,7 +4252,7 @@
                 <a:solidFill>
                   <a:srgbClr val="FFFFFF"/>
                 </a:solidFill>
-                <a:latin typeface="Arial"/>
+                <a:latin typeface="Segoe UI"/>
               </a:defRPr>
             </a:pPr>
             <a:r>
@@ -4016,14 +4263,59 @@
       </p:sp>
       <p:sp>
         <p:nvSpPr>
-          <p:cNvPr id="3" name="TextBox 2"/>
+          <p:cNvPr id="3" name="Rectangle 2"/>
+          <p:cNvSpPr/>
+          <p:nvPr/>
+        </p:nvSpPr>
+        <p:spPr>
+          <a:xfrm>
+            <a:off x="457200" y="1371600"/>
+            <a:ext cx="11274552" cy="5029200"/>
+          </a:xfrm>
+          <a:prstGeom prst="rect">
+            <a:avLst/>
+          </a:prstGeom>
+          <a:solidFill>
+            <a:srgbClr val="FFFFFF"/>
+          </a:solidFill>
+          <a:ln w="12700">
+            <a:solidFill>
+              <a:srgbClr val="E1E4E8"/>
+            </a:solidFill>
+          </a:ln>
+        </p:spPr>
+        <p:style>
+          <a:lnRef idx="1">
+            <a:schemeClr val="accent1"/>
+          </a:lnRef>
+          <a:fillRef idx="3">
+            <a:schemeClr val="accent1"/>
+          </a:fillRef>
+          <a:effectRef idx="2">
+            <a:schemeClr val="accent1"/>
+          </a:effectRef>
+          <a:fontRef idx="minor">
+            <a:schemeClr val="lt1"/>
+          </a:fontRef>
+        </p:style>
+        <p:txBody>
+          <a:bodyPr rtlCol="0" anchor="ctr"/>
+          <a:lstStyle/>
+          <a:p>
+            <a:pPr algn="ctr"/>
+          </a:p>
+        </p:txBody>
+      </p:sp>
+      <p:sp>
+        <p:nvSpPr>
+          <p:cNvPr id="4" name="TextBox 3"/>
           <p:cNvSpPr txBox="1"/>
           <p:nvPr/>
         </p:nvSpPr>
         <p:spPr>
           <a:xfrm>
-            <a:off x="457200" y="1463040"/>
-            <a:ext cx="11274552" cy="4937760"/>
+            <a:off x="731520" y="1554480"/>
+            <a:ext cx="10725912" cy="4663440"/>
           </a:xfrm>
           <a:prstGeom prst="rect">
             <a:avLst/>
@@ -4042,9 +4334,9 @@
               </a:spcAft>
               <a:defRPr sz="1800">
                 <a:solidFill>
-                  <a:srgbClr val="282828"/>
-                </a:solidFill>
-                <a:latin typeface="Arial"/>
+                  <a:srgbClr val="2C3E50"/>
+                </a:solidFill>
+                <a:latin typeface="Segoe UI"/>
               </a:defRPr>
             </a:pPr>
             <a:r>
@@ -4058,9 +4350,9 @@
               </a:spcAft>
               <a:defRPr sz="1600">
                 <a:solidFill>
-                  <a:srgbClr val="282828"/>
-                </a:solidFill>
-                <a:latin typeface="Arial"/>
+                  <a:srgbClr val="2C3E50"/>
+                </a:solidFill>
+                <a:latin typeface="Segoe UI"/>
               </a:defRPr>
             </a:pPr>
             <a:r>
@@ -4074,9 +4366,9 @@
               </a:spcAft>
               <a:defRPr sz="1600">
                 <a:solidFill>
-                  <a:srgbClr val="282828"/>
-                </a:solidFill>
-                <a:latin typeface="Arial"/>
+                  <a:srgbClr val="2C3E50"/>
+                </a:solidFill>
+                <a:latin typeface="Segoe UI"/>
               </a:defRPr>
             </a:pPr>
             <a:r>
@@ -4090,9 +4382,9 @@
               </a:spcAft>
               <a:defRPr sz="1600">
                 <a:solidFill>
-                  <a:srgbClr val="282828"/>
-                </a:solidFill>
-                <a:latin typeface="Arial"/>
+                  <a:srgbClr val="2C3E50"/>
+                </a:solidFill>
+                <a:latin typeface="Segoe UI"/>
               </a:defRPr>
             </a:pPr>
             <a:r>
@@ -4106,9 +4398,9 @@
               </a:spcAft>
               <a:defRPr sz="1800">
                 <a:solidFill>
-                  <a:srgbClr val="282828"/>
-                </a:solidFill>
-                <a:latin typeface="Arial"/>
+                  <a:srgbClr val="2C3E50"/>
+                </a:solidFill>
+                <a:latin typeface="Segoe UI"/>
               </a:defRPr>
             </a:pPr>
             <a:r>
@@ -4122,9 +4414,9 @@
               </a:spcAft>
               <a:defRPr sz="1600">
                 <a:solidFill>
-                  <a:srgbClr val="282828"/>
-                </a:solidFill>
-                <a:latin typeface="Arial"/>
+                  <a:srgbClr val="2C3E50"/>
+                </a:solidFill>
+                <a:latin typeface="Segoe UI"/>
               </a:defRPr>
             </a:pPr>
             <a:r>
@@ -4138,9 +4430,9 @@
               </a:spcAft>
               <a:defRPr sz="1600">
                 <a:solidFill>
-                  <a:srgbClr val="282828"/>
-                </a:solidFill>
-                <a:latin typeface="Arial"/>
+                  <a:srgbClr val="2C3E50"/>
+                </a:solidFill>
+                <a:latin typeface="Segoe UI"/>
               </a:defRPr>
             </a:pPr>
             <a:r>
@@ -4163,7 +4455,7 @@
     <p:bg>
       <p:bgPr>
         <a:solidFill>
-          <a:srgbClr val="F0F2F5"/>
+          <a:srgbClr val="F5F6F8"/>
         </a:solidFill>
         <a:effectLst/>
       </p:bgPr>
@@ -4213,7 +4505,7 @@
           </a:fontRef>
         </p:style>
         <p:txBody>
-          <a:bodyPr rtlCol="0" anchor="ctr" wrap="square" lIns="457200" tIns="274320"/>
+          <a:bodyPr rtlCol="0" anchor="ctr" wrap="square" lIns="548640" tIns="320040"/>
           <a:lstStyle/>
           <a:p>
             <a:pPr algn="l">
@@ -4221,7 +4513,7 @@
                 <a:solidFill>
                   <a:srgbClr val="FFFFFF"/>
                 </a:solidFill>
-                <a:latin typeface="Arial"/>
+                <a:latin typeface="Segoe UI"/>
               </a:defRPr>
             </a:pPr>
             <a:r>
@@ -4232,14 +4524,59 @@
       </p:sp>
       <p:sp>
         <p:nvSpPr>
-          <p:cNvPr id="3" name="TextBox 2"/>
+          <p:cNvPr id="3" name="Rectangle 2"/>
+          <p:cNvSpPr/>
+          <p:nvPr/>
+        </p:nvSpPr>
+        <p:spPr>
+          <a:xfrm>
+            <a:off x="457200" y="1371600"/>
+            <a:ext cx="11274552" cy="5029200"/>
+          </a:xfrm>
+          <a:prstGeom prst="rect">
+            <a:avLst/>
+          </a:prstGeom>
+          <a:solidFill>
+            <a:srgbClr val="FFFFFF"/>
+          </a:solidFill>
+          <a:ln w="12700">
+            <a:solidFill>
+              <a:srgbClr val="E1E4E8"/>
+            </a:solidFill>
+          </a:ln>
+        </p:spPr>
+        <p:style>
+          <a:lnRef idx="1">
+            <a:schemeClr val="accent1"/>
+          </a:lnRef>
+          <a:fillRef idx="3">
+            <a:schemeClr val="accent1"/>
+          </a:fillRef>
+          <a:effectRef idx="2">
+            <a:schemeClr val="accent1"/>
+          </a:effectRef>
+          <a:fontRef idx="minor">
+            <a:schemeClr val="lt1"/>
+          </a:fontRef>
+        </p:style>
+        <p:txBody>
+          <a:bodyPr rtlCol="0" anchor="ctr"/>
+          <a:lstStyle/>
+          <a:p>
+            <a:pPr algn="ctr"/>
+          </a:p>
+        </p:txBody>
+      </p:sp>
+      <p:sp>
+        <p:nvSpPr>
+          <p:cNvPr id="4" name="TextBox 3"/>
           <p:cNvSpPr txBox="1"/>
           <p:nvPr/>
         </p:nvSpPr>
         <p:spPr>
           <a:xfrm>
-            <a:off x="457200" y="1463040"/>
-            <a:ext cx="11274552" cy="4937760"/>
+            <a:off x="731520" y="1554480"/>
+            <a:ext cx="10725912" cy="4663440"/>
           </a:xfrm>
           <a:prstGeom prst="rect">
             <a:avLst/>
@@ -4258,9 +4595,9 @@
               </a:spcAft>
               <a:defRPr sz="1800">
                 <a:solidFill>
-                  <a:srgbClr val="282828"/>
-                </a:solidFill>
-                <a:latin typeface="Arial"/>
+                  <a:srgbClr val="2C3E50"/>
+                </a:solidFill>
+                <a:latin typeface="Segoe UI"/>
               </a:defRPr>
             </a:pPr>
             <a:r>
@@ -4274,9 +4611,9 @@
               </a:spcAft>
               <a:defRPr sz="1600">
                 <a:solidFill>
-                  <a:srgbClr val="282828"/>
-                </a:solidFill>
-                <a:latin typeface="Arial"/>
+                  <a:srgbClr val="2C3E50"/>
+                </a:solidFill>
+                <a:latin typeface="Segoe UI"/>
               </a:defRPr>
             </a:pPr>
             <a:r>
@@ -4290,9 +4627,9 @@
               </a:spcAft>
               <a:defRPr sz="1600">
                 <a:solidFill>
-                  <a:srgbClr val="282828"/>
-                </a:solidFill>
-                <a:latin typeface="Arial"/>
+                  <a:srgbClr val="2C3E50"/>
+                </a:solidFill>
+                <a:latin typeface="Segoe UI"/>
               </a:defRPr>
             </a:pPr>
             <a:r>
@@ -4306,9 +4643,9 @@
               </a:spcAft>
               <a:defRPr sz="1800">
                 <a:solidFill>
-                  <a:srgbClr val="282828"/>
-                </a:solidFill>
-                <a:latin typeface="Arial"/>
+                  <a:srgbClr val="2C3E50"/>
+                </a:solidFill>
+                <a:latin typeface="Segoe UI"/>
               </a:defRPr>
             </a:pPr>
             <a:r>
@@ -4322,9 +4659,9 @@
               </a:spcAft>
               <a:defRPr sz="1600">
                 <a:solidFill>
-                  <a:srgbClr val="282828"/>
-                </a:solidFill>
-                <a:latin typeface="Arial"/>
+                  <a:srgbClr val="2C3E50"/>
+                </a:solidFill>
+                <a:latin typeface="Segoe UI"/>
               </a:defRPr>
             </a:pPr>
             <a:r>
@@ -4338,9 +4675,9 @@
               </a:spcAft>
               <a:defRPr sz="1600">
                 <a:solidFill>
-                  <a:srgbClr val="282828"/>
-                </a:solidFill>
-                <a:latin typeface="Arial"/>
+                  <a:srgbClr val="2C3E50"/>
+                </a:solidFill>
+                <a:latin typeface="Segoe UI"/>
               </a:defRPr>
             </a:pPr>
             <a:r>
@@ -4354,9 +4691,9 @@
               </a:spcAft>
               <a:defRPr sz="1600">
                 <a:solidFill>
-                  <a:srgbClr val="282828"/>
-                </a:solidFill>
-                <a:latin typeface="Arial"/>
+                  <a:srgbClr val="2C3E50"/>
+                </a:solidFill>
+                <a:latin typeface="Segoe UI"/>
               </a:defRPr>
             </a:pPr>
             <a:r>
@@ -4379,7 +4716,7 @@
     <p:bg>
       <p:bgPr>
         <a:solidFill>
-          <a:srgbClr val="F0F2F5"/>
+          <a:srgbClr val="F5F6F8"/>
         </a:solidFill>
         <a:effectLst/>
       </p:bgPr>
@@ -4429,7 +4766,7 @@
           </a:fontRef>
         </p:style>
         <p:txBody>
-          <a:bodyPr rtlCol="0" anchor="ctr" wrap="square" lIns="457200" tIns="274320"/>
+          <a:bodyPr rtlCol="0" anchor="ctr" wrap="square" lIns="548640" tIns="320040"/>
           <a:lstStyle/>
           <a:p>
             <a:pPr algn="l">
@@ -4437,7 +4774,7 @@
                 <a:solidFill>
                   <a:srgbClr val="FFFFFF"/>
                 </a:solidFill>
-                <a:latin typeface="Arial"/>
+                <a:latin typeface="Segoe UI"/>
               </a:defRPr>
             </a:pPr>
             <a:r>
@@ -4448,14 +4785,59 @@
       </p:sp>
       <p:sp>
         <p:nvSpPr>
-          <p:cNvPr id="3" name="TextBox 2"/>
+          <p:cNvPr id="3" name="Rectangle 2"/>
+          <p:cNvSpPr/>
+          <p:nvPr/>
+        </p:nvSpPr>
+        <p:spPr>
+          <a:xfrm>
+            <a:off x="457200" y="1371600"/>
+            <a:ext cx="6583680" cy="5029200"/>
+          </a:xfrm>
+          <a:prstGeom prst="rect">
+            <a:avLst/>
+          </a:prstGeom>
+          <a:solidFill>
+            <a:srgbClr val="FFFFFF"/>
+          </a:solidFill>
+          <a:ln w="12700">
+            <a:solidFill>
+              <a:srgbClr val="E1E4E8"/>
+            </a:solidFill>
+          </a:ln>
+        </p:spPr>
+        <p:style>
+          <a:lnRef idx="1">
+            <a:schemeClr val="accent1"/>
+          </a:lnRef>
+          <a:fillRef idx="3">
+            <a:schemeClr val="accent1"/>
+          </a:fillRef>
+          <a:effectRef idx="2">
+            <a:schemeClr val="accent1"/>
+          </a:effectRef>
+          <a:fontRef idx="minor">
+            <a:schemeClr val="lt1"/>
+          </a:fontRef>
+        </p:style>
+        <p:txBody>
+          <a:bodyPr rtlCol="0" anchor="ctr"/>
+          <a:lstStyle/>
+          <a:p>
+            <a:pPr algn="ctr"/>
+          </a:p>
+        </p:txBody>
+      </p:sp>
+      <p:sp>
+        <p:nvSpPr>
+          <p:cNvPr id="4" name="TextBox 3"/>
           <p:cNvSpPr txBox="1"/>
           <p:nvPr/>
         </p:nvSpPr>
         <p:spPr>
           <a:xfrm>
-            <a:off x="457200" y="1463040"/>
-            <a:ext cx="11274552" cy="4937760"/>
+            <a:off x="640080" y="1554480"/>
+            <a:ext cx="6217920" cy="4663440"/>
           </a:xfrm>
           <a:prstGeom prst="rect">
             <a:avLst/>
@@ -4474,9 +4856,9 @@
               </a:spcAft>
               <a:defRPr sz="1800">
                 <a:solidFill>
-                  <a:srgbClr val="282828"/>
-                </a:solidFill>
-                <a:latin typeface="Arial"/>
+                  <a:srgbClr val="2C3E50"/>
+                </a:solidFill>
+                <a:latin typeface="Segoe UI"/>
               </a:defRPr>
             </a:pPr>
             <a:r>
@@ -4490,9 +4872,9 @@
               </a:spcAft>
               <a:defRPr sz="1600">
                 <a:solidFill>
-                  <a:srgbClr val="282828"/>
-                </a:solidFill>
-                <a:latin typeface="Arial"/>
+                  <a:srgbClr val="2C3E50"/>
+                </a:solidFill>
+                <a:latin typeface="Segoe UI"/>
               </a:defRPr>
             </a:pPr>
             <a:r>
@@ -4506,9 +4888,9 @@
               </a:spcAft>
               <a:defRPr sz="1600">
                 <a:solidFill>
-                  <a:srgbClr val="282828"/>
-                </a:solidFill>
-                <a:latin typeface="Arial"/>
+                  <a:srgbClr val="2C3E50"/>
+                </a:solidFill>
+                <a:latin typeface="Segoe UI"/>
               </a:defRPr>
             </a:pPr>
             <a:r>
@@ -4522,9 +4904,9 @@
               </a:spcAft>
               <a:defRPr sz="1800">
                 <a:solidFill>
-                  <a:srgbClr val="282828"/>
-                </a:solidFill>
-                <a:latin typeface="Arial"/>
+                  <a:srgbClr val="2C3E50"/>
+                </a:solidFill>
+                <a:latin typeface="Segoe UI"/>
               </a:defRPr>
             </a:pPr>
             <a:r>
@@ -4538,9 +4920,9 @@
               </a:spcAft>
               <a:defRPr sz="1600">
                 <a:solidFill>
-                  <a:srgbClr val="282828"/>
-                </a:solidFill>
-                <a:latin typeface="Arial"/>
+                  <a:srgbClr val="2C3E50"/>
+                </a:solidFill>
+                <a:latin typeface="Segoe UI"/>
               </a:defRPr>
             </a:pPr>
             <a:r>
@@ -4554,9 +4936,9 @@
               </a:spcAft>
               <a:defRPr sz="1600">
                 <a:solidFill>
-                  <a:srgbClr val="282828"/>
-                </a:solidFill>
-                <a:latin typeface="Arial"/>
+                  <a:srgbClr val="2C3E50"/>
+                </a:solidFill>
+                <a:latin typeface="Segoe UI"/>
               </a:defRPr>
             </a:pPr>
             <a:r>
@@ -4570,9 +4952,9 @@
               </a:spcAft>
               <a:defRPr sz="1600">
                 <a:solidFill>
-                  <a:srgbClr val="282828"/>
-                </a:solidFill>
-                <a:latin typeface="Arial"/>
+                  <a:srgbClr val="2C3E50"/>
+                </a:solidFill>
+                <a:latin typeface="Segoe UI"/>
               </a:defRPr>
             </a:pPr>
             <a:r>
@@ -4581,6 +4963,75 @@
           </a:p>
         </p:txBody>
       </p:sp>
+      <p:sp>
+        <p:nvSpPr>
+          <p:cNvPr id="5" name="Rectangle 4"/>
+          <p:cNvSpPr/>
+          <p:nvPr/>
+        </p:nvSpPr>
+        <p:spPr>
+          <a:xfrm>
+            <a:off x="7315200" y="1371600"/>
+            <a:ext cx="4416552" cy="5029200"/>
+          </a:xfrm>
+          <a:prstGeom prst="rect">
+            <a:avLst/>
+          </a:prstGeom>
+          <a:solidFill>
+            <a:srgbClr val="FFFFFF"/>
+          </a:solidFill>
+          <a:ln w="12700">
+            <a:solidFill>
+              <a:srgbClr val="E1E4E8"/>
+            </a:solidFill>
+          </a:ln>
+        </p:spPr>
+        <p:style>
+          <a:lnRef idx="1">
+            <a:schemeClr val="accent1"/>
+          </a:lnRef>
+          <a:fillRef idx="3">
+            <a:schemeClr val="accent1"/>
+          </a:fillRef>
+          <a:effectRef idx="2">
+            <a:schemeClr val="accent1"/>
+          </a:effectRef>
+          <a:fontRef idx="minor">
+            <a:schemeClr val="lt1"/>
+          </a:fontRef>
+        </p:style>
+        <p:txBody>
+          <a:bodyPr rtlCol="0" anchor="ctr"/>
+          <a:lstStyle/>
+          <a:p>
+            <a:pPr algn="ctr"/>
+          </a:p>
+        </p:txBody>
+      </p:sp>
+      <p:pic>
+        <p:nvPicPr>
+          <p:cNvPr id="6" name="Picture 5" descr="webrtc.png"/>
+          <p:cNvPicPr>
+            <a:picLocks noChangeAspect="1"/>
+          </p:cNvPicPr>
+          <p:nvPr/>
+        </p:nvPicPr>
+        <p:blipFill>
+          <a:blip r:embed="rId2"/>
+          <a:stretch>
+            <a:fillRect/>
+          </a:stretch>
+        </p:blipFill>
+        <p:spPr>
+          <a:xfrm>
+            <a:off x="7498079" y="1554480"/>
+            <a:ext cx="4050791" cy="4663440"/>
+          </a:xfrm>
+          <a:prstGeom prst="rect">
+            <a:avLst/>
+          </a:prstGeom>
+        </p:spPr>
+      </p:pic>
     </p:spTree>
   </p:cSld>
   <p:clrMapOvr>
@@ -4595,7 +5046,7 @@
     <p:bg>
       <p:bgPr>
         <a:solidFill>
-          <a:srgbClr val="F0F2F5"/>
+          <a:srgbClr val="F5F6F8"/>
         </a:solidFill>
         <a:effectLst/>
       </p:bgPr>
@@ -4645,7 +5096,7 @@
           </a:fontRef>
         </p:style>
         <p:txBody>
-          <a:bodyPr rtlCol="0" anchor="ctr" wrap="square" lIns="457200" tIns="274320"/>
+          <a:bodyPr rtlCol="0" anchor="ctr" wrap="square" lIns="548640" tIns="320040"/>
           <a:lstStyle/>
           <a:p>
             <a:pPr algn="l">
@@ -4653,7 +5104,7 @@
                 <a:solidFill>
                   <a:srgbClr val="FFFFFF"/>
                 </a:solidFill>
-                <a:latin typeface="Arial"/>
+                <a:latin typeface="Segoe UI"/>
               </a:defRPr>
             </a:pPr>
             <a:r>
@@ -4664,14 +5115,59 @@
       </p:sp>
       <p:sp>
         <p:nvSpPr>
-          <p:cNvPr id="3" name="TextBox 2"/>
+          <p:cNvPr id="3" name="Rectangle 2"/>
+          <p:cNvSpPr/>
+          <p:nvPr/>
+        </p:nvSpPr>
+        <p:spPr>
+          <a:xfrm>
+            <a:off x="457200" y="1371600"/>
+            <a:ext cx="11274552" cy="5029200"/>
+          </a:xfrm>
+          <a:prstGeom prst="rect">
+            <a:avLst/>
+          </a:prstGeom>
+          <a:solidFill>
+            <a:srgbClr val="FFFFFF"/>
+          </a:solidFill>
+          <a:ln w="12700">
+            <a:solidFill>
+              <a:srgbClr val="E1E4E8"/>
+            </a:solidFill>
+          </a:ln>
+        </p:spPr>
+        <p:style>
+          <a:lnRef idx="1">
+            <a:schemeClr val="accent1"/>
+          </a:lnRef>
+          <a:fillRef idx="3">
+            <a:schemeClr val="accent1"/>
+          </a:fillRef>
+          <a:effectRef idx="2">
+            <a:schemeClr val="accent1"/>
+          </a:effectRef>
+          <a:fontRef idx="minor">
+            <a:schemeClr val="lt1"/>
+          </a:fontRef>
+        </p:style>
+        <p:txBody>
+          <a:bodyPr rtlCol="0" anchor="ctr"/>
+          <a:lstStyle/>
+          <a:p>
+            <a:pPr algn="ctr"/>
+          </a:p>
+        </p:txBody>
+      </p:sp>
+      <p:sp>
+        <p:nvSpPr>
+          <p:cNvPr id="4" name="TextBox 3"/>
           <p:cNvSpPr txBox="1"/>
           <p:nvPr/>
         </p:nvSpPr>
         <p:spPr>
           <a:xfrm>
-            <a:off x="457200" y="1463040"/>
-            <a:ext cx="11274552" cy="4937760"/>
+            <a:off x="731520" y="1554480"/>
+            <a:ext cx="10725912" cy="4663440"/>
           </a:xfrm>
           <a:prstGeom prst="rect">
             <a:avLst/>
@@ -4690,9 +5186,9 @@
               </a:spcAft>
               <a:defRPr sz="1800">
                 <a:solidFill>
-                  <a:srgbClr val="282828"/>
-                </a:solidFill>
-                <a:latin typeface="Arial"/>
+                  <a:srgbClr val="2C3E50"/>
+                </a:solidFill>
+                <a:latin typeface="Segoe UI"/>
               </a:defRPr>
             </a:pPr>
             <a:r>
@@ -4706,9 +5202,9 @@
               </a:spcAft>
               <a:defRPr sz="1600">
                 <a:solidFill>
-                  <a:srgbClr val="282828"/>
-                </a:solidFill>
-                <a:latin typeface="Arial"/>
+                  <a:srgbClr val="2C3E50"/>
+                </a:solidFill>
+                <a:latin typeface="Segoe UI"/>
               </a:defRPr>
             </a:pPr>
             <a:r>
@@ -4722,9 +5218,9 @@
               </a:spcAft>
               <a:defRPr sz="1600">
                 <a:solidFill>
-                  <a:srgbClr val="282828"/>
-                </a:solidFill>
-                <a:latin typeface="Arial"/>
+                  <a:srgbClr val="2C3E50"/>
+                </a:solidFill>
+                <a:latin typeface="Segoe UI"/>
               </a:defRPr>
             </a:pPr>
             <a:r>
@@ -4738,9 +5234,9 @@
               </a:spcAft>
               <a:defRPr sz="1600">
                 <a:solidFill>
-                  <a:srgbClr val="282828"/>
-                </a:solidFill>
-                <a:latin typeface="Arial"/>
+                  <a:srgbClr val="2C3E50"/>
+                </a:solidFill>
+                <a:latin typeface="Segoe UI"/>
               </a:defRPr>
             </a:pPr>
             <a:r>
@@ -4754,9 +5250,9 @@
               </a:spcAft>
               <a:defRPr sz="1800">
                 <a:solidFill>
-                  <a:srgbClr val="282828"/>
-                </a:solidFill>
-                <a:latin typeface="Arial"/>
+                  <a:srgbClr val="2C3E50"/>
+                </a:solidFill>
+                <a:latin typeface="Segoe UI"/>
               </a:defRPr>
             </a:pPr>
             <a:r>
@@ -4770,9 +5266,9 @@
               </a:spcAft>
               <a:defRPr sz="1600">
                 <a:solidFill>
-                  <a:srgbClr val="282828"/>
-                </a:solidFill>
-                <a:latin typeface="Arial"/>
+                  <a:srgbClr val="2C3E50"/>
+                </a:solidFill>
+                <a:latin typeface="Segoe UI"/>
               </a:defRPr>
             </a:pPr>
             <a:r>
@@ -4786,9 +5282,9 @@
               </a:spcAft>
               <a:defRPr sz="1600">
                 <a:solidFill>
-                  <a:srgbClr val="282828"/>
-                </a:solidFill>
-                <a:latin typeface="Arial"/>
+                  <a:srgbClr val="2C3E50"/>
+                </a:solidFill>
+                <a:latin typeface="Segoe UI"/>
               </a:defRPr>
             </a:pPr>
             <a:r>
@@ -4811,7 +5307,7 @@
     <p:bg>
       <p:bgPr>
         <a:solidFill>
-          <a:srgbClr val="F0F2F5"/>
+          <a:srgbClr val="F5F6F8"/>
         </a:solidFill>
         <a:effectLst/>
       </p:bgPr>
@@ -4861,7 +5357,7 @@
           </a:fontRef>
         </p:style>
         <p:txBody>
-          <a:bodyPr rtlCol="0" anchor="ctr" wrap="square" lIns="457200" tIns="274320"/>
+          <a:bodyPr rtlCol="0" anchor="ctr" wrap="square" lIns="548640" tIns="320040"/>
           <a:lstStyle/>
           <a:p>
             <a:pPr algn="l">
@@ -4869,7 +5365,7 @@
                 <a:solidFill>
                   <a:srgbClr val="FFFFFF"/>
                 </a:solidFill>
-                <a:latin typeface="Arial"/>
+                <a:latin typeface="Segoe UI"/>
               </a:defRPr>
             </a:pPr>
             <a:r>
@@ -4880,14 +5376,59 @@
       </p:sp>
       <p:sp>
         <p:nvSpPr>
-          <p:cNvPr id="3" name="TextBox 2"/>
+          <p:cNvPr id="3" name="Rectangle 2"/>
+          <p:cNvSpPr/>
+          <p:nvPr/>
+        </p:nvSpPr>
+        <p:spPr>
+          <a:xfrm>
+            <a:off x="457200" y="1371600"/>
+            <a:ext cx="11274552" cy="5029200"/>
+          </a:xfrm>
+          <a:prstGeom prst="rect">
+            <a:avLst/>
+          </a:prstGeom>
+          <a:solidFill>
+            <a:srgbClr val="FFFFFF"/>
+          </a:solidFill>
+          <a:ln w="12700">
+            <a:solidFill>
+              <a:srgbClr val="E1E4E8"/>
+            </a:solidFill>
+          </a:ln>
+        </p:spPr>
+        <p:style>
+          <a:lnRef idx="1">
+            <a:schemeClr val="accent1"/>
+          </a:lnRef>
+          <a:fillRef idx="3">
+            <a:schemeClr val="accent1"/>
+          </a:fillRef>
+          <a:effectRef idx="2">
+            <a:schemeClr val="accent1"/>
+          </a:effectRef>
+          <a:fontRef idx="minor">
+            <a:schemeClr val="lt1"/>
+          </a:fontRef>
+        </p:style>
+        <p:txBody>
+          <a:bodyPr rtlCol="0" anchor="ctr"/>
+          <a:lstStyle/>
+          <a:p>
+            <a:pPr algn="ctr"/>
+          </a:p>
+        </p:txBody>
+      </p:sp>
+      <p:sp>
+        <p:nvSpPr>
+          <p:cNvPr id="4" name="TextBox 3"/>
           <p:cNvSpPr txBox="1"/>
           <p:nvPr/>
         </p:nvSpPr>
         <p:spPr>
           <a:xfrm>
-            <a:off x="457200" y="1463040"/>
-            <a:ext cx="11274552" cy="4937760"/>
+            <a:off x="731520" y="1554480"/>
+            <a:ext cx="10725912" cy="4663440"/>
           </a:xfrm>
           <a:prstGeom prst="rect">
             <a:avLst/>
@@ -4906,9 +5447,9 @@
               </a:spcAft>
               <a:defRPr sz="1800">
                 <a:solidFill>
-                  <a:srgbClr val="282828"/>
-                </a:solidFill>
-                <a:latin typeface="Arial"/>
+                  <a:srgbClr val="2C3E50"/>
+                </a:solidFill>
+                <a:latin typeface="Segoe UI"/>
               </a:defRPr>
             </a:pPr>
             <a:r>
@@ -4922,9 +5463,9 @@
               </a:spcAft>
               <a:defRPr sz="1600">
                 <a:solidFill>
-                  <a:srgbClr val="282828"/>
-                </a:solidFill>
-                <a:latin typeface="Arial"/>
+                  <a:srgbClr val="2C3E50"/>
+                </a:solidFill>
+                <a:latin typeface="Segoe UI"/>
               </a:defRPr>
             </a:pPr>
             <a:r>
@@ -4938,9 +5479,9 @@
               </a:spcAft>
               <a:defRPr sz="1600">
                 <a:solidFill>
-                  <a:srgbClr val="282828"/>
-                </a:solidFill>
-                <a:latin typeface="Arial"/>
+                  <a:srgbClr val="2C3E50"/>
+                </a:solidFill>
+                <a:latin typeface="Segoe UI"/>
               </a:defRPr>
             </a:pPr>
             <a:r>
@@ -4954,9 +5495,9 @@
               </a:spcAft>
               <a:defRPr sz="1800">
                 <a:solidFill>
-                  <a:srgbClr val="282828"/>
-                </a:solidFill>
-                <a:latin typeface="Arial"/>
+                  <a:srgbClr val="2C3E50"/>
+                </a:solidFill>
+                <a:latin typeface="Segoe UI"/>
               </a:defRPr>
             </a:pPr>
             <a:r>
@@ -4970,9 +5511,9 @@
               </a:spcAft>
               <a:defRPr sz="1600">
                 <a:solidFill>
-                  <a:srgbClr val="282828"/>
-                </a:solidFill>
-                <a:latin typeface="Arial"/>
+                  <a:srgbClr val="2C3E50"/>
+                </a:solidFill>
+                <a:latin typeface="Segoe UI"/>
               </a:defRPr>
             </a:pPr>
             <a:r>
@@ -4986,9 +5527,9 @@
               </a:spcAft>
               <a:defRPr sz="1600">
                 <a:solidFill>
-                  <a:srgbClr val="282828"/>
-                </a:solidFill>
-                <a:latin typeface="Arial"/>
+                  <a:srgbClr val="2C3E50"/>
+                </a:solidFill>
+                <a:latin typeface="Segoe UI"/>
               </a:defRPr>
             </a:pPr>
             <a:r>
@@ -5002,9 +5543,9 @@
               </a:spcAft>
               <a:defRPr sz="1600">
                 <a:solidFill>
-                  <a:srgbClr val="282828"/>
-                </a:solidFill>
-                <a:latin typeface="Arial"/>
+                  <a:srgbClr val="2C3E50"/>
+                </a:solidFill>
+                <a:latin typeface="Segoe UI"/>
               </a:defRPr>
             </a:pPr>
             <a:r>
@@ -5027,7 +5568,7 @@
     <p:bg>
       <p:bgPr>
         <a:solidFill>
-          <a:srgbClr val="F0F2F5"/>
+          <a:srgbClr val="F5F6F8"/>
         </a:solidFill>
         <a:effectLst/>
       </p:bgPr>
@@ -5077,7 +5618,7 @@
           </a:fontRef>
         </p:style>
         <p:txBody>
-          <a:bodyPr rtlCol="0" anchor="ctr" wrap="square" lIns="457200" tIns="274320"/>
+          <a:bodyPr rtlCol="0" anchor="ctr" wrap="square" lIns="548640" tIns="320040"/>
           <a:lstStyle/>
           <a:p>
             <a:pPr algn="l">
@@ -5085,7 +5626,7 @@
                 <a:solidFill>
                   <a:srgbClr val="FFFFFF"/>
                 </a:solidFill>
-                <a:latin typeface="Arial"/>
+                <a:latin typeface="Segoe UI"/>
               </a:defRPr>
             </a:pPr>
             <a:r>
@@ -5096,14 +5637,59 @@
       </p:sp>
       <p:sp>
         <p:nvSpPr>
-          <p:cNvPr id="3" name="TextBox 2"/>
+          <p:cNvPr id="3" name="Rectangle 2"/>
+          <p:cNvSpPr/>
+          <p:nvPr/>
+        </p:nvSpPr>
+        <p:spPr>
+          <a:xfrm>
+            <a:off x="457200" y="1371600"/>
+            <a:ext cx="6583680" cy="5029200"/>
+          </a:xfrm>
+          <a:prstGeom prst="rect">
+            <a:avLst/>
+          </a:prstGeom>
+          <a:solidFill>
+            <a:srgbClr val="FFFFFF"/>
+          </a:solidFill>
+          <a:ln w="12700">
+            <a:solidFill>
+              <a:srgbClr val="E1E4E8"/>
+            </a:solidFill>
+          </a:ln>
+        </p:spPr>
+        <p:style>
+          <a:lnRef idx="1">
+            <a:schemeClr val="accent1"/>
+          </a:lnRef>
+          <a:fillRef idx="3">
+            <a:schemeClr val="accent1"/>
+          </a:fillRef>
+          <a:effectRef idx="2">
+            <a:schemeClr val="accent1"/>
+          </a:effectRef>
+          <a:fontRef idx="minor">
+            <a:schemeClr val="lt1"/>
+          </a:fontRef>
+        </p:style>
+        <p:txBody>
+          <a:bodyPr rtlCol="0" anchor="ctr"/>
+          <a:lstStyle/>
+          <a:p>
+            <a:pPr algn="ctr"/>
+          </a:p>
+        </p:txBody>
+      </p:sp>
+      <p:sp>
+        <p:nvSpPr>
+          <p:cNvPr id="4" name="TextBox 3"/>
           <p:cNvSpPr txBox="1"/>
           <p:nvPr/>
         </p:nvSpPr>
         <p:spPr>
           <a:xfrm>
-            <a:off x="457200" y="1463040"/>
-            <a:ext cx="11274552" cy="4937760"/>
+            <a:off x="640080" y="1554480"/>
+            <a:ext cx="6217920" cy="4663440"/>
           </a:xfrm>
           <a:prstGeom prst="rect">
             <a:avLst/>
@@ -5122,9 +5708,9 @@
               </a:spcAft>
               <a:defRPr sz="1800">
                 <a:solidFill>
-                  <a:srgbClr val="282828"/>
-                </a:solidFill>
-                <a:latin typeface="Arial"/>
+                  <a:srgbClr val="2C3E50"/>
+                </a:solidFill>
+                <a:latin typeface="Segoe UI"/>
               </a:defRPr>
             </a:pPr>
             <a:r>
@@ -5138,9 +5724,9 @@
               </a:spcAft>
               <a:defRPr sz="1600">
                 <a:solidFill>
-                  <a:srgbClr val="282828"/>
-                </a:solidFill>
-                <a:latin typeface="Arial"/>
+                  <a:srgbClr val="2C3E50"/>
+                </a:solidFill>
+                <a:latin typeface="Segoe UI"/>
               </a:defRPr>
             </a:pPr>
             <a:r>
@@ -5154,9 +5740,9 @@
               </a:spcAft>
               <a:defRPr sz="1600">
                 <a:solidFill>
-                  <a:srgbClr val="282828"/>
-                </a:solidFill>
-                <a:latin typeface="Arial"/>
+                  <a:srgbClr val="2C3E50"/>
+                </a:solidFill>
+                <a:latin typeface="Segoe UI"/>
               </a:defRPr>
             </a:pPr>
             <a:r>
@@ -5170,9 +5756,9 @@
               </a:spcAft>
               <a:defRPr sz="1800">
                 <a:solidFill>
-                  <a:srgbClr val="282828"/>
-                </a:solidFill>
-                <a:latin typeface="Arial"/>
+                  <a:srgbClr val="2C3E50"/>
+                </a:solidFill>
+                <a:latin typeface="Segoe UI"/>
               </a:defRPr>
             </a:pPr>
             <a:r>
@@ -5186,9 +5772,9 @@
               </a:spcAft>
               <a:defRPr sz="1600">
                 <a:solidFill>
-                  <a:srgbClr val="282828"/>
-                </a:solidFill>
-                <a:latin typeface="Arial"/>
+                  <a:srgbClr val="2C3E50"/>
+                </a:solidFill>
+                <a:latin typeface="Segoe UI"/>
               </a:defRPr>
             </a:pPr>
             <a:r>
@@ -5202,9 +5788,9 @@
               </a:spcAft>
               <a:defRPr sz="1800">
                 <a:solidFill>
-                  <a:srgbClr val="282828"/>
-                </a:solidFill>
-                <a:latin typeface="Arial"/>
+                  <a:srgbClr val="2C3E50"/>
+                </a:solidFill>
+                <a:latin typeface="Segoe UI"/>
               </a:defRPr>
             </a:pPr>
             <a:r>
@@ -5218,9 +5804,9 @@
               </a:spcAft>
               <a:defRPr sz="1600">
                 <a:solidFill>
-                  <a:srgbClr val="282828"/>
-                </a:solidFill>
-                <a:latin typeface="Arial"/>
+                  <a:srgbClr val="2C3E50"/>
+                </a:solidFill>
+                <a:latin typeface="Segoe UI"/>
               </a:defRPr>
             </a:pPr>
             <a:r>
@@ -5234,9 +5820,9 @@
               </a:spcAft>
               <a:defRPr sz="1600">
                 <a:solidFill>
-                  <a:srgbClr val="282828"/>
-                </a:solidFill>
-                <a:latin typeface="Arial"/>
+                  <a:srgbClr val="2C3E50"/>
+                </a:solidFill>
+                <a:latin typeface="Segoe UI"/>
               </a:defRPr>
             </a:pPr>
             <a:r>
@@ -5245,6 +5831,75 @@
           </a:p>
         </p:txBody>
       </p:sp>
+      <p:sp>
+        <p:nvSpPr>
+          <p:cNvPr id="5" name="Rectangle 4"/>
+          <p:cNvSpPr/>
+          <p:nvPr/>
+        </p:nvSpPr>
+        <p:spPr>
+          <a:xfrm>
+            <a:off x="7315200" y="1371600"/>
+            <a:ext cx="4416552" cy="5029200"/>
+          </a:xfrm>
+          <a:prstGeom prst="rect">
+            <a:avLst/>
+          </a:prstGeom>
+          <a:solidFill>
+            <a:srgbClr val="FFFFFF"/>
+          </a:solidFill>
+          <a:ln w="12700">
+            <a:solidFill>
+              <a:srgbClr val="E1E4E8"/>
+            </a:solidFill>
+          </a:ln>
+        </p:spPr>
+        <p:style>
+          <a:lnRef idx="1">
+            <a:schemeClr val="accent1"/>
+          </a:lnRef>
+          <a:fillRef idx="3">
+            <a:schemeClr val="accent1"/>
+          </a:fillRef>
+          <a:effectRef idx="2">
+            <a:schemeClr val="accent1"/>
+          </a:effectRef>
+          <a:fontRef idx="minor">
+            <a:schemeClr val="lt1"/>
+          </a:fontRef>
+        </p:style>
+        <p:txBody>
+          <a:bodyPr rtlCol="0" anchor="ctr"/>
+          <a:lstStyle/>
+          <a:p>
+            <a:pPr algn="ctr"/>
+          </a:p>
+        </p:txBody>
+      </p:sp>
+      <p:pic>
+        <p:nvPicPr>
+          <p:cNvPr id="6" name="Picture 5" descr="personalization.png"/>
+          <p:cNvPicPr>
+            <a:picLocks noChangeAspect="1"/>
+          </p:cNvPicPr>
+          <p:nvPr/>
+        </p:nvPicPr>
+        <p:blipFill>
+          <a:blip r:embed="rId2"/>
+          <a:stretch>
+            <a:fillRect/>
+          </a:stretch>
+        </p:blipFill>
+        <p:spPr>
+          <a:xfrm>
+            <a:off x="7498079" y="1554480"/>
+            <a:ext cx="4050791" cy="4663440"/>
+          </a:xfrm>
+          <a:prstGeom prst="rect">
+            <a:avLst/>
+          </a:prstGeom>
+        </p:spPr>
+      </p:pic>
     </p:spTree>
   </p:cSld>
   <p:clrMapOvr>

</xml_diff>